<commit_message>
Submission deck: live numbers on Opportunities, one real check slide with the agent graph, clickable links
</commit_message>
<xml_diff>
--- a/submission/SKUdesk-AI-Builder-Cup.pptx
+++ b/submission/SKUdesk-AI-Builder-Cup.pptx
@@ -10,6 +10,7 @@
     <p:sldId id="258" r:id="rId10"/>
     <p:sldId id="259" r:id="rId11"/>
     <p:sldId id="260" r:id="rId12"/>
+    <p:sldId id="268" r:id="rId20"/>
     <p:sldId id="261" r:id="rId13"/>
     <p:sldId id="262" r:id="rId14"/>
     <p:sldId id="263" r:id="rId15"/>
@@ -4082,6 +4083,7 @@
                   <a:srgbClr val="555B66"/>
                 </a:solidFill>
                 <a:latin typeface="Arial"/>
+                <a:hlinkClick r:id="rId3"/>
               </a:rPr>
               <a:t>https://github.com/johnnyduo/SKUdesk_</a:t>
             </a:r>
@@ -4107,6 +4109,7 @@
                   <a:srgbClr val="555B66"/>
                 </a:solidFill>
                 <a:latin typeface="Arial"/>
+                <a:hlinkClick r:id="rId4"/>
               </a:rPr>
               <a:t>https://youtu.be/DgpX9r0xt9Y</a:t>
             </a:r>
@@ -4132,6 +4135,7 @@
                   <a:srgbClr val="555B66"/>
                 </a:solidFill>
                 <a:latin typeface="Arial"/>
+                <a:hlinkClick r:id="rId5"/>
               </a:rPr>
               <a:t>https://skudesk.lol</a:t>
             </a:r>
@@ -4188,6 +4192,1315 @@
 </p:sld>
 </file>
 
+<file path=ppt/slides/slide13.xml><?xml version="1.0" encoding="utf-8"?>
+<p:sld xmlns:a="http://schemas.openxmlformats.org/drawingml/2006/main" xmlns:p="http://schemas.openxmlformats.org/presentationml/2006/main" xmlns:r="http://schemas.openxmlformats.org/officeDocument/2006/relationships">
+  <p:cSld>
+    <p:spTree>
+      <p:nvGrpSpPr>
+        <p:cNvPr id="1" name=""/>
+        <p:cNvGrpSpPr/>
+        <p:nvPr/>
+      </p:nvGrpSpPr>
+      <p:grpSpPr/>
+      <p:pic>
+        <p:nvPicPr>
+          <p:cNvPr id="2" name="Picture 1" descr="image.png"/>
+          <p:cNvPicPr>
+            <a:picLocks noChangeAspect="1"/>
+          </p:cNvPicPr>
+          <p:nvPr/>
+        </p:nvPicPr>
+        <p:blipFill>
+          <a:blip r:embed="rId2"/>
+          <a:stretch>
+            <a:fillRect/>
+          </a:stretch>
+        </p:blipFill>
+        <p:spPr>
+          <a:xfrm>
+            <a:off x="0" y="0"/>
+            <a:ext cx="12191695" cy="6858000"/>
+          </a:xfrm>
+          <a:prstGeom prst="rect">
+            <a:avLst/>
+          </a:prstGeom>
+        </p:spPr>
+      </p:pic>
+      <p:sp>
+        <p:nvSpPr>
+          <p:cNvPr id="3" name="TextBox 2"/>
+          <p:cNvSpPr txBox="1"/>
+          <p:nvPr/>
+        </p:nvSpPr>
+        <p:spPr>
+          <a:xfrm>
+            <a:off x="457200" y="914400"/>
+            <a:ext cx="11300000" cy="548640"/>
+          </a:xfrm>
+          <a:prstGeom prst="rect">
+            <a:avLst/>
+          </a:prstGeom>
+          <a:noFill/>
+        </p:spPr>
+        <p:txBody>
+          <a:bodyPr wrap="square" anchor="t" lIns="45720" rIns="45720">
+            <a:spAutoFit/>
+          </a:bodyPr>
+          <a:lstStyle/>
+          <a:p>
+            <a:pPr algn="l">
+              <a:spcAft>
+                <a:spcPts val="0"/>
+              </a:spcAft>
+            </a:pPr>
+            <a:r>
+              <a:rPr sz="2600" b="1">
+                <a:solidFill>
+                  <a:srgbClr val="000000"/>
+                </a:solidFill>
+                <a:latin typeface="Arial"/>
+              </a:rPr>
+              <a:t>The agent at work: one real check</a:t>
+            </a:r>
+          </a:p>
+        </p:txBody>
+      </p:sp>
+      <p:sp>
+        <p:nvSpPr>
+          <p:cNvPr id="4" name="TextBox 3"/>
+          <p:cNvSpPr txBox="1"/>
+          <p:nvPr/>
+        </p:nvSpPr>
+        <p:spPr>
+          <a:xfrm>
+            <a:off x="457200" y="1417320"/>
+            <a:ext cx="11247120" cy="320040"/>
+          </a:xfrm>
+          <a:prstGeom prst="rect">
+            <a:avLst/>
+          </a:prstGeom>
+          <a:noFill/>
+        </p:spPr>
+        <p:txBody>
+          <a:bodyPr wrap="square" anchor="t" lIns="45720" rIns="45720">
+            <a:spAutoFit/>
+          </a:bodyPr>
+          <a:lstStyle/>
+          <a:p>
+            <a:pPr algn="l">
+              <a:spcAft>
+                <a:spcPts val="0"/>
+              </a:spcAft>
+            </a:pPr>
+            <a:r>
+              <a:rPr sz="1300" b="0">
+                <a:solidFill>
+                  <a:srgbClr val="555B66"/>
+                </a:solidFill>
+                <a:latin typeface="Arial"/>
+              </a:rPr>
+              <a:t>LEGO Technic Ferrari Daytona SP3 (42143), checked on skudesk.lol with real Google Shopping listings and real Gemini verdicts.</a:t>
+            </a:r>
+          </a:p>
+        </p:txBody>
+      </p:sp>
+      <p:pic>
+        <p:nvPicPr>
+          <p:cNvPr id="5" name="Picture 4" descr="agent-crop.png"/>
+          <p:cNvPicPr>
+            <a:picLocks noChangeAspect="1"/>
+          </p:cNvPicPr>
+          <p:nvPr/>
+        </p:nvPicPr>
+        <p:blipFill>
+          <a:blip r:embed="rId3"/>
+          <a:stretch>
+            <a:fillRect/>
+          </a:stretch>
+        </p:blipFill>
+        <p:spPr>
+          <a:xfrm>
+            <a:off x="457200" y="1828800"/>
+            <a:ext cx="5943600" cy="1485900"/>
+          </a:xfrm>
+          <a:prstGeom prst="rect">
+            <a:avLst/>
+          </a:prstGeom>
+        </p:spPr>
+      </p:pic>
+      <p:sp>
+        <p:nvSpPr>
+          <p:cNvPr id="6" name="TextBox 5"/>
+          <p:cNvSpPr txBox="1"/>
+          <p:nvPr/>
+        </p:nvSpPr>
+        <p:spPr>
+          <a:xfrm>
+            <a:off x="457200" y="3351276"/>
+            <a:ext cx="5943600" cy="640080"/>
+          </a:xfrm>
+          <a:prstGeom prst="rect">
+            <a:avLst/>
+          </a:prstGeom>
+          <a:noFill/>
+        </p:spPr>
+        <p:txBody>
+          <a:bodyPr wrap="square" anchor="t" lIns="45720" rIns="45720">
+            <a:spAutoFit/>
+          </a:bodyPr>
+          <a:lstStyle/>
+          <a:p>
+            <a:pPr algn="l">
+              <a:spcAft>
+                <a:spcPts val="0"/>
+              </a:spcAft>
+            </a:pPr>
+            <a:r>
+              <a:rPr sz="1050" b="1">
+                <a:solidFill>
+                  <a:srgbClr val="000000"/>
+                </a:solidFill>
+                <a:latin typeface="Arial"/>
+              </a:rPr>
+              <a:t>Live agent graph, from the demo recording (a check of an iPhone 16e). </a:t>
+            </a:r>
+            <a:r>
+              <a:rPr sz="1050" b="0">
+                <a:solidFill>
+                  <a:srgbClr val="555B66"/>
+                </a:solidFill>
+                <a:latin typeface="Arial"/>
+              </a:rPr>
+              <a:t>Every dot is one listing moving through six stages: green = identical, red = a different product, amber = not provable.</a:t>
+            </a:r>
+          </a:p>
+        </p:txBody>
+      </p:sp>
+      <p:sp>
+        <p:nvSpPr>
+          <p:cNvPr id="7" name="Rounded Rectangle 6"/>
+          <p:cNvSpPr/>
+          <p:nvPr/>
+        </p:nvSpPr>
+        <p:spPr>
+          <a:xfrm>
+            <a:off x="6675120" y="1828800"/>
+            <a:ext cx="1572768" cy="749808"/>
+          </a:xfrm>
+          <a:prstGeom prst="roundRect">
+            <a:avLst>
+              <a:gd name="adj" fmla="val 10000"/>
+            </a:avLst>
+          </a:prstGeom>
+          <a:solidFill>
+            <a:srgbClr val="0B0B0F"/>
+          </a:solidFill>
+          <a:ln>
+            <a:noFill/>
+          </a:ln>
+          <a:effectLst/>
+        </p:spPr>
+        <p:style>
+          <a:lnRef idx="1">
+            <a:schemeClr val="accent1"/>
+          </a:lnRef>
+          <a:fillRef idx="3">
+            <a:schemeClr val="accent1"/>
+          </a:fillRef>
+          <a:effectRef idx="2">
+            <a:schemeClr val="accent1"/>
+          </a:effectRef>
+          <a:fontRef idx="minor">
+            <a:schemeClr val="lt1"/>
+          </a:fontRef>
+        </p:style>
+        <p:txBody>
+          <a:bodyPr rtlCol="0" anchor="ctr" wrap="square" lIns="70000" rIns="70000"/>
+          <a:lstStyle/>
+          <a:p>
+            <a:pPr algn="ctr"/>
+            <a:r>
+              <a:rPr sz="2600" b="1">
+                <a:solidFill>
+                  <a:srgbClr val="FFFFFF"/>
+                </a:solidFill>
+                <a:latin typeface="Arial"/>
+              </a:rPr>
+              <a:t>40</a:t>
+            </a:r>
+          </a:p>
+          <a:p>
+            <a:pPr algn="ctr"/>
+            <a:r>
+              <a:rPr sz="1100" b="0">
+                <a:solidFill>
+                  <a:srgbClr val="DDE1E6"/>
+                </a:solidFill>
+                <a:latin typeface="Arial"/>
+              </a:rPr>
+              <a:t>listings found</a:t>
+            </a:r>
+          </a:p>
+        </p:txBody>
+      </p:sp>
+      <p:sp>
+        <p:nvSpPr>
+          <p:cNvPr id="8" name="Rounded Rectangle 7"/>
+          <p:cNvSpPr/>
+          <p:nvPr/>
+        </p:nvSpPr>
+        <p:spPr>
+          <a:xfrm>
+            <a:off x="8357616" y="1828800"/>
+            <a:ext cx="1572768" cy="749808"/>
+          </a:xfrm>
+          <a:prstGeom prst="roundRect">
+            <a:avLst>
+              <a:gd name="adj" fmla="val 10000"/>
+            </a:avLst>
+          </a:prstGeom>
+          <a:solidFill>
+            <a:srgbClr val="0B0B0F"/>
+          </a:solidFill>
+          <a:ln>
+            <a:noFill/>
+          </a:ln>
+          <a:effectLst/>
+        </p:spPr>
+        <p:style>
+          <a:lnRef idx="1">
+            <a:schemeClr val="accent1"/>
+          </a:lnRef>
+          <a:fillRef idx="3">
+            <a:schemeClr val="accent1"/>
+          </a:fillRef>
+          <a:effectRef idx="2">
+            <a:schemeClr val="accent1"/>
+          </a:effectRef>
+          <a:fontRef idx="minor">
+            <a:schemeClr val="lt1"/>
+          </a:fontRef>
+        </p:style>
+        <p:txBody>
+          <a:bodyPr rtlCol="0" anchor="ctr" wrap="square" lIns="70000" rIns="70000"/>
+          <a:lstStyle/>
+          <a:p>
+            <a:pPr algn="ctr"/>
+            <a:r>
+              <a:rPr sz="2600" b="1">
+                <a:solidFill>
+                  <a:srgbClr val="FFFFFF"/>
+                </a:solidFill>
+                <a:latin typeface="Arial"/>
+              </a:rPr>
+              <a:t>30</a:t>
+            </a:r>
+          </a:p>
+          <a:p>
+            <a:pPr algn="ctr"/>
+            <a:r>
+              <a:rPr sz="1100" b="0">
+                <a:solidFill>
+                  <a:srgbClr val="DDE1E6"/>
+                </a:solidFill>
+                <a:latin typeface="Arial"/>
+              </a:rPr>
+              <a:t>judged by Gemini</a:t>
+            </a:r>
+          </a:p>
+        </p:txBody>
+      </p:sp>
+      <p:sp>
+        <p:nvSpPr>
+          <p:cNvPr id="9" name="Rounded Rectangle 8"/>
+          <p:cNvSpPr/>
+          <p:nvPr/>
+        </p:nvSpPr>
+        <p:spPr>
+          <a:xfrm>
+            <a:off x="10040112" y="1828800"/>
+            <a:ext cx="1572768" cy="749808"/>
+          </a:xfrm>
+          <a:prstGeom prst="roundRect">
+            <a:avLst>
+              <a:gd name="adj" fmla="val 10000"/>
+            </a:avLst>
+          </a:prstGeom>
+          <a:solidFill>
+            <a:srgbClr val="0B0B0F"/>
+          </a:solidFill>
+          <a:ln>
+            <a:noFill/>
+          </a:ln>
+          <a:effectLst/>
+        </p:spPr>
+        <p:style>
+          <a:lnRef idx="1">
+            <a:schemeClr val="accent1"/>
+          </a:lnRef>
+          <a:fillRef idx="3">
+            <a:schemeClr val="accent1"/>
+          </a:fillRef>
+          <a:effectRef idx="2">
+            <a:schemeClr val="accent1"/>
+          </a:effectRef>
+          <a:fontRef idx="minor">
+            <a:schemeClr val="lt1"/>
+          </a:fontRef>
+        </p:style>
+        <p:txBody>
+          <a:bodyPr rtlCol="0" anchor="ctr" wrap="square" lIns="70000" rIns="70000"/>
+          <a:lstStyle/>
+          <a:p>
+            <a:pPr algn="ctr"/>
+            <a:r>
+              <a:rPr sz="2600" b="1">
+                <a:solidFill>
+                  <a:srgbClr val="CCFF00"/>
+                </a:solidFill>
+                <a:latin typeface="Arial"/>
+              </a:rPr>
+              <a:t>6</a:t>
+            </a:r>
+          </a:p>
+          <a:p>
+            <a:pPr algn="ctr"/>
+            <a:r>
+              <a:rPr sz="1100" b="0">
+                <a:solidFill>
+                  <a:srgbClr val="DDE1E6"/>
+                </a:solidFill>
+                <a:latin typeface="Arial"/>
+              </a:rPr>
+              <a:t>identical</a:t>
+            </a:r>
+          </a:p>
+        </p:txBody>
+      </p:sp>
+      <p:sp>
+        <p:nvSpPr>
+          <p:cNvPr id="10" name="Rounded Rectangle 9"/>
+          <p:cNvSpPr/>
+          <p:nvPr/>
+        </p:nvSpPr>
+        <p:spPr>
+          <a:xfrm>
+            <a:off x="6675120" y="2688336"/>
+            <a:ext cx="1572768" cy="749808"/>
+          </a:xfrm>
+          <a:prstGeom prst="roundRect">
+            <a:avLst>
+              <a:gd name="adj" fmla="val 10000"/>
+            </a:avLst>
+          </a:prstGeom>
+          <a:solidFill>
+            <a:srgbClr val="0B0B0F"/>
+          </a:solidFill>
+          <a:ln>
+            <a:noFill/>
+          </a:ln>
+          <a:effectLst/>
+        </p:spPr>
+        <p:style>
+          <a:lnRef idx="1">
+            <a:schemeClr val="accent1"/>
+          </a:lnRef>
+          <a:fillRef idx="3">
+            <a:schemeClr val="accent1"/>
+          </a:fillRef>
+          <a:effectRef idx="2">
+            <a:schemeClr val="accent1"/>
+          </a:effectRef>
+          <a:fontRef idx="minor">
+            <a:schemeClr val="lt1"/>
+          </a:fontRef>
+        </p:style>
+        <p:txBody>
+          <a:bodyPr rtlCol="0" anchor="ctr" wrap="square" lIns="70000" rIns="70000"/>
+          <a:lstStyle/>
+          <a:p>
+            <a:pPr algn="ctr"/>
+            <a:r>
+              <a:rPr sz="2600" b="1">
+                <a:solidFill>
+                  <a:srgbClr val="FF8A80"/>
+                </a:solidFill>
+                <a:latin typeface="Arial"/>
+              </a:rPr>
+              <a:t>20</a:t>
+            </a:r>
+          </a:p>
+          <a:p>
+            <a:pPr algn="ctr"/>
+            <a:r>
+              <a:rPr sz="1100" b="0">
+                <a:solidFill>
+                  <a:srgbClr val="DDE1E6"/>
+                </a:solidFill>
+                <a:latin typeface="Arial"/>
+              </a:rPr>
+              <a:t>different product</a:t>
+            </a:r>
+          </a:p>
+        </p:txBody>
+      </p:sp>
+      <p:sp>
+        <p:nvSpPr>
+          <p:cNvPr id="11" name="Rounded Rectangle 10"/>
+          <p:cNvSpPr/>
+          <p:nvPr/>
+        </p:nvSpPr>
+        <p:spPr>
+          <a:xfrm>
+            <a:off x="8357616" y="2688336"/>
+            <a:ext cx="1572768" cy="749808"/>
+          </a:xfrm>
+          <a:prstGeom prst="roundRect">
+            <a:avLst>
+              <a:gd name="adj" fmla="val 10000"/>
+            </a:avLst>
+          </a:prstGeom>
+          <a:solidFill>
+            <a:srgbClr val="0B0B0F"/>
+          </a:solidFill>
+          <a:ln>
+            <a:noFill/>
+          </a:ln>
+          <a:effectLst/>
+        </p:spPr>
+        <p:style>
+          <a:lnRef idx="1">
+            <a:schemeClr val="accent1"/>
+          </a:lnRef>
+          <a:fillRef idx="3">
+            <a:schemeClr val="accent1"/>
+          </a:fillRef>
+          <a:effectRef idx="2">
+            <a:schemeClr val="accent1"/>
+          </a:effectRef>
+          <a:fontRef idx="minor">
+            <a:schemeClr val="lt1"/>
+          </a:fontRef>
+        </p:style>
+        <p:txBody>
+          <a:bodyPr rtlCol="0" anchor="ctr" wrap="square" lIns="70000" rIns="70000"/>
+          <a:lstStyle/>
+          <a:p>
+            <a:pPr algn="ctr"/>
+            <a:r>
+              <a:rPr sz="2600" b="1">
+                <a:solidFill>
+                  <a:srgbClr val="FFD06B"/>
+                </a:solidFill>
+                <a:latin typeface="Arial"/>
+              </a:rPr>
+              <a:t>4</a:t>
+            </a:r>
+          </a:p>
+          <a:p>
+            <a:pPr algn="ctr"/>
+            <a:r>
+              <a:rPr sz="1100" b="0">
+                <a:solidFill>
+                  <a:srgbClr val="DDE1E6"/>
+                </a:solidFill>
+                <a:latin typeface="Arial"/>
+              </a:rPr>
+              <a:t>not provable</a:t>
+            </a:r>
+          </a:p>
+        </p:txBody>
+      </p:sp>
+      <p:sp>
+        <p:nvSpPr>
+          <p:cNvPr id="12" name="Rounded Rectangle 11"/>
+          <p:cNvSpPr/>
+          <p:nvPr/>
+        </p:nvSpPr>
+        <p:spPr>
+          <a:xfrm>
+            <a:off x="10040112" y="2688336"/>
+            <a:ext cx="1572768" cy="749808"/>
+          </a:xfrm>
+          <a:prstGeom prst="roundRect">
+            <a:avLst>
+              <a:gd name="adj" fmla="val 10000"/>
+            </a:avLst>
+          </a:prstGeom>
+          <a:solidFill>
+            <a:srgbClr val="0B0B0F"/>
+          </a:solidFill>
+          <a:ln>
+            <a:noFill/>
+          </a:ln>
+          <a:effectLst/>
+        </p:spPr>
+        <p:style>
+          <a:lnRef idx="1">
+            <a:schemeClr val="accent1"/>
+          </a:lnRef>
+          <a:fillRef idx="3">
+            <a:schemeClr val="accent1"/>
+          </a:fillRef>
+          <a:effectRef idx="2">
+            <a:schemeClr val="accent1"/>
+          </a:effectRef>
+          <a:fontRef idx="minor">
+            <a:schemeClr val="lt1"/>
+          </a:fontRef>
+        </p:style>
+        <p:txBody>
+          <a:bodyPr rtlCol="0" anchor="ctr" wrap="square" lIns="70000" rIns="70000"/>
+          <a:lstStyle/>
+          <a:p>
+            <a:pPr algn="ctr"/>
+            <a:r>
+              <a:rPr sz="2600" b="1">
+                <a:solidFill>
+                  <a:srgbClr val="FFFFFF"/>
+                </a:solidFill>
+                <a:latin typeface="Arial"/>
+              </a:rPr>
+              <a:t>3</a:t>
+            </a:r>
+          </a:p>
+          <a:p>
+            <a:pPr algn="ctr"/>
+            <a:r>
+              <a:rPr sz="1100" b="0">
+                <a:solidFill>
+                  <a:srgbClr val="DDE1E6"/>
+                </a:solidFill>
+                <a:latin typeface="Arial"/>
+              </a:rPr>
+              <a:t>bad prices set aside</a:t>
+            </a:r>
+          </a:p>
+        </p:txBody>
+      </p:sp>
+      <p:sp>
+        <p:nvSpPr>
+          <p:cNvPr id="13" name="TextBox 12"/>
+          <p:cNvSpPr txBox="1"/>
+          <p:nvPr/>
+        </p:nvSpPr>
+        <p:spPr>
+          <a:xfrm>
+            <a:off x="6675120" y="3529584"/>
+            <a:ext cx="4937760" cy="457200"/>
+          </a:xfrm>
+          <a:prstGeom prst="rect">
+            <a:avLst/>
+          </a:prstGeom>
+          <a:noFill/>
+        </p:spPr>
+        <p:txBody>
+          <a:bodyPr wrap="square" anchor="t" lIns="45720" rIns="45720">
+            <a:spAutoFit/>
+          </a:bodyPr>
+          <a:lstStyle/>
+          <a:p>
+            <a:pPr algn="l">
+              <a:spcAft>
+                <a:spcPts val="0"/>
+              </a:spcAft>
+            </a:pPr>
+            <a:r>
+              <a:rPr sz="1050" b="0">
+                <a:solidFill>
+                  <a:srgbClr val="555B66"/>
+                </a:solidFill>
+                <a:latin typeface="Arial"/>
+              </a:rPr>
+              <a:t>Of the 6 identical, 3 had prices that cannot be real ($5.83, $29.00 and $200.00 for a set that retails near $449.99), so only 3 were priced.</a:t>
+            </a:r>
+          </a:p>
+        </p:txBody>
+      </p:sp>
+      <p:graphicFrame>
+        <p:nvGraphicFramePr>
+          <p:cNvPr id="14" name="Table 13"/>
+          <p:cNvGraphicFramePr>
+            <a:graphicFrameLocks noGrp="1"/>
+          </p:cNvGraphicFramePr>
+          <p:nvPr/>
+        </p:nvGraphicFramePr>
+        <p:xfrm>
+          <a:off x="457200" y="4224528"/>
+          <a:ext cx="5897880" cy="1975104"/>
+        </p:xfrm>
+        <a:graphic>
+          <a:graphicData uri="http://schemas.openxmlformats.org/drawingml/2006/table">
+            <a:tbl>
+              <a:tblPr firstRow="1" bandRow="1">
+                <a:tableStyleId>{5C22544A-7EE6-4342-B048-85BDC9FD1C3A}</a:tableStyleId>
+              </a:tblPr>
+              <a:tblGrid>
+                <a:gridCol w="2788920"/>
+                <a:gridCol w="1051560"/>
+                <a:gridCol w="2057400"/>
+              </a:tblGrid>
+              <a:tr h="329184">
+                <a:tc>
+                  <a:txBody>
+                    <a:bodyPr/>
+                    <a:lstStyle/>
+                    <a:p>
+                      <a:r>
+                        <a:rPr sz="1050" b="1">
+                          <a:solidFill>
+                            <a:srgbClr val="FFFFFF"/>
+                          </a:solidFill>
+                          <a:latin typeface="Arial"/>
+                        </a:rPr>
+                        <a:t>Listing</a:t>
+                      </a:r>
+                    </a:p>
+                  </a:txBody>
+                  <a:tcPr marL="60000" marR="60000" marT="25000" marB="25000" anchor="ctr">
+                    <a:solidFill>
+                      <a:srgbClr val="0B0B0F"/>
+                    </a:solidFill>
+                  </a:tcPr>
+                </a:tc>
+                <a:tc>
+                  <a:txBody>
+                    <a:bodyPr/>
+                    <a:lstStyle/>
+                    <a:p>
+                      <a:r>
+                        <a:rPr sz="1050" b="1">
+                          <a:solidFill>
+                            <a:srgbClr val="FFFFFF"/>
+                          </a:solidFill>
+                          <a:latin typeface="Arial"/>
+                        </a:rPr>
+                        <a:t>Verdict</a:t>
+                      </a:r>
+                    </a:p>
+                  </a:txBody>
+                  <a:tcPr marL="60000" marR="60000" marT="25000" marB="25000" anchor="ctr">
+                    <a:solidFill>
+                      <a:srgbClr val="0B0B0F"/>
+                    </a:solidFill>
+                  </a:tcPr>
+                </a:tc>
+                <a:tc>
+                  <a:txBody>
+                    <a:bodyPr/>
+                    <a:lstStyle/>
+                    <a:p>
+                      <a:r>
+                        <a:rPr sz="1050" b="1">
+                          <a:solidFill>
+                            <a:srgbClr val="FFFFFF"/>
+                          </a:solidFill>
+                          <a:latin typeface="Arial"/>
+                        </a:rPr>
+                        <a:t>Why</a:t>
+                      </a:r>
+                    </a:p>
+                  </a:txBody>
+                  <a:tcPr marL="60000" marR="60000" marT="25000" marB="25000" anchor="ctr">
+                    <a:solidFill>
+                      <a:srgbClr val="0B0B0F"/>
+                    </a:solidFill>
+                  </a:tcPr>
+                </a:tc>
+              </a:tr>
+              <a:tr h="329184">
+                <a:tc>
+                  <a:txBody>
+                    <a:bodyPr/>
+                    <a:lstStyle/>
+                    <a:p>
+                      <a:r>
+                        <a:rPr sz="1050" b="0">
+                          <a:solidFill>
+                            <a:srgbClr val="555B66"/>
+                          </a:solidFill>
+                          <a:latin typeface="Arial"/>
+                        </a:rPr>
+                        <a:t>Ferrari Daytona SP3 “The Sense of Perfection” book</a:t>
+                      </a:r>
+                    </a:p>
+                  </a:txBody>
+                  <a:tcPr marL="60000" marR="60000" marT="25000" marB="25000" anchor="ctr">
+                    <a:solidFill>
+                      <a:srgbClr val="FFFFFF"/>
+                    </a:solidFill>
+                  </a:tcPr>
+                </a:tc>
+                <a:tc>
+                  <a:txBody>
+                    <a:bodyPr/>
+                    <a:lstStyle/>
+                    <a:p>
+                      <a:r>
+                        <a:rPr sz="1050" b="1">
+                          <a:solidFill>
+                            <a:srgbClr val="C5221F"/>
+                          </a:solidFill>
+                          <a:latin typeface="Arial"/>
+                        </a:rPr>
+                        <a:t>Different</a:t>
+                      </a:r>
+                    </a:p>
+                  </a:txBody>
+                  <a:tcPr marL="60000" marR="60000" marT="25000" marB="25000" anchor="ctr">
+                    <a:solidFill>
+                      <a:srgbClr val="FFFFFF"/>
+                    </a:solidFill>
+                  </a:tcPr>
+                </a:tc>
+                <a:tc>
+                  <a:txBody>
+                    <a:bodyPr/>
+                    <a:lstStyle/>
+                    <a:p>
+                      <a:r>
+                        <a:rPr sz="1050" b="0">
+                          <a:solidFill>
+                            <a:srgbClr val="555B66"/>
+                          </a:solidFill>
+                          <a:latin typeface="Arial"/>
+                        </a:rPr>
+                        <a:t>A book, not the set</a:t>
+                      </a:r>
+                    </a:p>
+                  </a:txBody>
+                  <a:tcPr marL="60000" marR="60000" marT="25000" marB="25000" anchor="ctr">
+                    <a:solidFill>
+                      <a:srgbClr val="FFFFFF"/>
+                    </a:solidFill>
+                  </a:tcPr>
+                </a:tc>
+              </a:tr>
+              <a:tr h="329184">
+                <a:tc>
+                  <a:txBody>
+                    <a:bodyPr/>
+                    <a:lstStyle/>
+                    <a:p>
+                      <a:r>
+                        <a:rPr sz="1050" b="0">
+                          <a:solidFill>
+                            <a:srgbClr val="555B66"/>
+                          </a:solidFill>
+                          <a:latin typeface="Arial"/>
+                        </a:rPr>
+                        <a:t>Brickshell Cases Wall Display Frame</a:t>
+                      </a:r>
+                    </a:p>
+                  </a:txBody>
+                  <a:tcPr marL="60000" marR="60000" marT="25000" marB="25000" anchor="ctr">
+                    <a:solidFill>
+                      <a:srgbClr val="F1F3F4"/>
+                    </a:solidFill>
+                  </a:tcPr>
+                </a:tc>
+                <a:tc>
+                  <a:txBody>
+                    <a:bodyPr/>
+                    <a:lstStyle/>
+                    <a:p>
+                      <a:r>
+                        <a:rPr sz="1050" b="1">
+                          <a:solidFill>
+                            <a:srgbClr val="C5221F"/>
+                          </a:solidFill>
+                          <a:latin typeface="Arial"/>
+                        </a:rPr>
+                        <a:t>Different</a:t>
+                      </a:r>
+                    </a:p>
+                  </a:txBody>
+                  <a:tcPr marL="60000" marR="60000" marT="25000" marB="25000" anchor="ctr">
+                    <a:solidFill>
+                      <a:srgbClr val="F1F3F4"/>
+                    </a:solidFill>
+                  </a:tcPr>
+                </a:tc>
+                <a:tc>
+                  <a:txBody>
+                    <a:bodyPr/>
+                    <a:lstStyle/>
+                    <a:p>
+                      <a:r>
+                        <a:rPr sz="1050" b="0">
+                          <a:solidFill>
+                            <a:srgbClr val="555B66"/>
+                          </a:solidFill>
+                          <a:latin typeface="Arial"/>
+                        </a:rPr>
+                        <a:t>An accessory, not the set</a:t>
+                      </a:r>
+                    </a:p>
+                  </a:txBody>
+                  <a:tcPr marL="60000" marR="60000" marT="25000" marB="25000" anchor="ctr">
+                    <a:solidFill>
+                      <a:srgbClr val="F1F3F4"/>
+                    </a:solidFill>
+                  </a:tcPr>
+                </a:tc>
+              </a:tr>
+              <a:tr h="329184">
+                <a:tc>
+                  <a:txBody>
+                    <a:bodyPr/>
+                    <a:lstStyle/>
+                    <a:p>
+                      <a:r>
+                        <a:rPr sz="1050" b="0">
+                          <a:solidFill>
+                            <a:srgbClr val="555B66"/>
+                          </a:solidFill>
+                          <a:latin typeface="Arial"/>
+                        </a:rPr>
+                        <a:t>“KING 8888 compatible 42143” building blocks</a:t>
+                      </a:r>
+                    </a:p>
+                  </a:txBody>
+                  <a:tcPr marL="60000" marR="60000" marT="25000" marB="25000" anchor="ctr">
+                    <a:solidFill>
+                      <a:srgbClr val="FFFFFF"/>
+                    </a:solidFill>
+                  </a:tcPr>
+                </a:tc>
+                <a:tc>
+                  <a:txBody>
+                    <a:bodyPr/>
+                    <a:lstStyle/>
+                    <a:p>
+                      <a:r>
+                        <a:rPr sz="1050" b="1">
+                          <a:solidFill>
+                            <a:srgbClr val="C5221F"/>
+                          </a:solidFill>
+                          <a:latin typeface="Arial"/>
+                        </a:rPr>
+                        <a:t>Different</a:t>
+                      </a:r>
+                    </a:p>
+                  </a:txBody>
+                  <a:tcPr marL="60000" marR="60000" marT="25000" marB="25000" anchor="ctr">
+                    <a:solidFill>
+                      <a:srgbClr val="FFFFFF"/>
+                    </a:solidFill>
+                  </a:tcPr>
+                </a:tc>
+                <a:tc>
+                  <a:txBody>
+                    <a:bodyPr/>
+                    <a:lstStyle/>
+                    <a:p>
+                      <a:r>
+                        <a:rPr sz="1050" b="0">
+                          <a:solidFill>
+                            <a:srgbClr val="555B66"/>
+                          </a:solidFill>
+                          <a:latin typeface="Arial"/>
+                        </a:rPr>
+                        <a:t>Other brand: a clone</a:t>
+                      </a:r>
+                    </a:p>
+                  </a:txBody>
+                  <a:tcPr marL="60000" marR="60000" marT="25000" marB="25000" anchor="ctr">
+                    <a:solidFill>
+                      <a:srgbClr val="FFFFFF"/>
+                    </a:solidFill>
+                  </a:tcPr>
+                </a:tc>
+              </a:tr>
+              <a:tr h="329184">
+                <a:tc>
+                  <a:txBody>
+                    <a:bodyPr/>
+                    <a:lstStyle/>
+                    <a:p>
+                      <a:r>
+                        <a:rPr sz="1050" b="0">
+                          <a:solidFill>
+                            <a:srgbClr val="555B66"/>
+                          </a:solidFill>
+                          <a:latin typeface="Arial"/>
+                        </a:rPr>
+                        <a:t>eBay 42143 “Collectible Supercar Building Kit”</a:t>
+                      </a:r>
+                    </a:p>
+                  </a:txBody>
+                  <a:tcPr marL="60000" marR="60000" marT="25000" marB="25000" anchor="ctr">
+                    <a:solidFill>
+                      <a:srgbClr val="F1F3F4"/>
+                    </a:solidFill>
+                  </a:tcPr>
+                </a:tc>
+                <a:tc>
+                  <a:txBody>
+                    <a:bodyPr/>
+                    <a:lstStyle/>
+                    <a:p>
+                      <a:r>
+                        <a:rPr sz="1050" b="1">
+                          <a:solidFill>
+                            <a:srgbClr val="B06000"/>
+                          </a:solidFill>
+                          <a:latin typeface="Arial"/>
+                        </a:rPr>
+                        <a:t>Not provable</a:t>
+                      </a:r>
+                    </a:p>
+                  </a:txBody>
+                  <a:tcPr marL="60000" marR="60000" marT="25000" marB="25000" anchor="ctr">
+                    <a:solidFill>
+                      <a:srgbClr val="F1F3F4"/>
+                    </a:solidFill>
+                  </a:tcPr>
+                </a:tc>
+                <a:tc>
+                  <a:txBody>
+                    <a:bodyPr/>
+                    <a:lstStyle/>
+                    <a:p>
+                      <a:r>
+                        <a:rPr sz="1050" b="0">
+                          <a:solidFill>
+                            <a:srgbClr val="555B66"/>
+                          </a:solidFill>
+                          <a:latin typeface="Arial"/>
+                        </a:rPr>
+                        <a:t>Brand not found in the listing</a:t>
+                      </a:r>
+                    </a:p>
+                  </a:txBody>
+                  <a:tcPr marL="60000" marR="60000" marT="25000" marB="25000" anchor="ctr">
+                    <a:solidFill>
+                      <a:srgbClr val="F1F3F4"/>
+                    </a:solidFill>
+                  </a:tcPr>
+                </a:tc>
+              </a:tr>
+              <a:tr h="329184">
+                <a:tc>
+                  <a:txBody>
+                    <a:bodyPr/>
+                    <a:lstStyle/>
+                    <a:p>
+                      <a:r>
+                        <a:rPr sz="1050" b="0">
+                          <a:solidFill>
+                            <a:srgbClr val="555B66"/>
+                          </a:solidFill>
+                          <a:latin typeface="Arial"/>
+                        </a:rPr>
+                        <a:t>eBay LEGO Ferrari 42143 at $5.83</a:t>
+                      </a:r>
+                    </a:p>
+                  </a:txBody>
+                  <a:tcPr marL="60000" marR="60000" marT="25000" marB="25000" anchor="ctr">
+                    <a:solidFill>
+                      <a:srgbClr val="FFFFFF"/>
+                    </a:solidFill>
+                  </a:tcPr>
+                </a:tc>
+                <a:tc>
+                  <a:txBody>
+                    <a:bodyPr/>
+                    <a:lstStyle/>
+                    <a:p>
+                      <a:r>
+                        <a:rPr sz="1050" b="1">
+                          <a:solidFill>
+                            <a:srgbClr val="B06000"/>
+                          </a:solidFill>
+                          <a:latin typeface="Arial"/>
+                        </a:rPr>
+                        <a:t>Set aside</a:t>
+                      </a:r>
+                    </a:p>
+                  </a:txBody>
+                  <a:tcPr marL="60000" marR="60000" marT="25000" marB="25000" anchor="ctr">
+                    <a:solidFill>
+                      <a:srgbClr val="FFFFFF"/>
+                    </a:solidFill>
+                  </a:tcPr>
+                </a:tc>
+                <a:tc>
+                  <a:txBody>
+                    <a:bodyPr/>
+                    <a:lstStyle/>
+                    <a:p>
+                      <a:r>
+                        <a:rPr sz="1050" b="0">
+                          <a:solidFill>
+                            <a:srgbClr val="555B66"/>
+                          </a:solidFill>
+                          <a:latin typeface="Arial"/>
+                        </a:rPr>
+                        <a:t>Impossible next to $449.99 retail</a:t>
+                      </a:r>
+                    </a:p>
+                  </a:txBody>
+                  <a:tcPr marL="60000" marR="60000" marT="25000" marB="25000" anchor="ctr">
+                    <a:solidFill>
+                      <a:srgbClr val="FFFFFF"/>
+                    </a:solidFill>
+                  </a:tcPr>
+                </a:tc>
+              </a:tr>
+            </a:tbl>
+          </a:graphicData>
+        </a:graphic>
+      </p:graphicFrame>
+      <p:sp>
+        <p:nvSpPr>
+          <p:cNvPr id="15" name="TextBox 14"/>
+          <p:cNvSpPr txBox="1"/>
+          <p:nvPr/>
+        </p:nvSpPr>
+        <p:spPr>
+          <a:xfrm>
+            <a:off x="457200" y="3895344"/>
+            <a:ext cx="6400800" cy="310896"/>
+          </a:xfrm>
+          <a:prstGeom prst="rect">
+            <a:avLst/>
+          </a:prstGeom>
+          <a:noFill/>
+        </p:spPr>
+        <p:txBody>
+          <a:bodyPr wrap="square" anchor="t" lIns="45720" rIns="45720">
+            <a:spAutoFit/>
+          </a:bodyPr>
+          <a:lstStyle/>
+          <a:p>
+            <a:pPr algn="l">
+              <a:spcAft>
+                <a:spcPts val="0"/>
+              </a:spcAft>
+            </a:pPr>
+            <a:r>
+              <a:rPr sz="1200" b="1">
+                <a:solidFill>
+                  <a:srgbClr val="000000"/>
+                </a:solidFill>
+                <a:latin typeface="Arial"/>
+              </a:rPr>
+              <a:t>Five listings the agent did not trade on, and why</a:t>
+            </a:r>
+          </a:p>
+        </p:txBody>
+      </p:sp>
+      <p:sp>
+        <p:nvSpPr>
+          <p:cNvPr id="16" name="Rounded Rectangle 15"/>
+          <p:cNvSpPr/>
+          <p:nvPr/>
+        </p:nvSpPr>
+        <p:spPr>
+          <a:xfrm>
+            <a:off x="6675120" y="4041648"/>
+            <a:ext cx="5029200" cy="2267712"/>
+          </a:xfrm>
+          <a:prstGeom prst="roundRect">
+            <a:avLst>
+              <a:gd name="adj" fmla="val 10000"/>
+            </a:avLst>
+          </a:prstGeom>
+          <a:solidFill>
+            <a:srgbClr val="0B0B0F"/>
+          </a:solidFill>
+          <a:ln>
+            <a:noFill/>
+          </a:ln>
+          <a:effectLst/>
+        </p:spPr>
+        <p:style>
+          <a:lnRef idx="1">
+            <a:schemeClr val="accent1"/>
+          </a:lnRef>
+          <a:fillRef idx="3">
+            <a:schemeClr val="accent1"/>
+          </a:fillRef>
+          <a:effectRef idx="2">
+            <a:schemeClr val="accent1"/>
+          </a:effectRef>
+          <a:fontRef idx="minor">
+            <a:schemeClr val="lt1"/>
+          </a:fontRef>
+        </p:style>
+        <p:txBody>
+          <a:bodyPr rtlCol="0" anchor="ctr" wrap="square" lIns="150000" rIns="150000"/>
+          <a:lstStyle/>
+          <a:p>
+            <a:pPr algn="l">
+              <a:spcAft>
+                <a:spcPts val="700"/>
+              </a:spcAft>
+            </a:pPr>
+            <a:r>
+              <a:rPr sz="1250" b="0">
+                <a:solidFill>
+                  <a:srgbClr val="DDE1E6"/>
+                </a:solidFill>
+                <a:latin typeface="Arial"/>
+              </a:rPr>
+              <a:t>Buy </a:t>
+            </a:r>
+            <a:r>
+              <a:rPr sz="1250" b="1">
+                <a:solidFill>
+                  <a:srgbClr val="FFFFFF"/>
+                </a:solidFill>
+                <a:latin typeface="Arial"/>
+              </a:rPr>
+              <a:t>BrickFever $525.00 landed</a:t>
+            </a:r>
+            <a:r>
+              <a:rPr sz="1250" b="0">
+                <a:solidFill>
+                  <a:srgbClr val="9AA3B2"/>
+                </a:solidFill>
+                <a:latin typeface="Arial"/>
+              </a:rPr>
+              <a:t> ($515.00 + $10.00 assumed shipping)</a:t>
+            </a:r>
+          </a:p>
+          <a:p>
+            <a:pPr algn="l">
+              <a:spcAft>
+                <a:spcPts val="700"/>
+              </a:spcAft>
+            </a:pPr>
+            <a:r>
+              <a:rPr sz="1250" b="0">
+                <a:solidFill>
+                  <a:srgbClr val="DDE1E6"/>
+                </a:solidFill>
+                <a:latin typeface="Arial"/>
+              </a:rPr>
+              <a:t>Resell at </a:t>
+            </a:r>
+            <a:r>
+              <a:rPr sz="1250" b="1">
+                <a:solidFill>
+                  <a:srgbClr val="FFFFFF"/>
+                </a:solidFill>
+                <a:latin typeface="Arial"/>
+              </a:rPr>
+              <a:t>$700.42</a:t>
+            </a:r>
+            <a:r>
+              <a:rPr sz="1250" b="0">
+                <a:solidFill>
+                  <a:srgbClr val="9AA3B2"/>
+                </a:solidFill>
+                <a:latin typeface="Arial"/>
+              </a:rPr>
+              <a:t> (next cheapest identical ask)</a:t>
+            </a:r>
+          </a:p>
+          <a:p>
+            <a:pPr algn="l">
+              <a:spcAft>
+                <a:spcPts val="700"/>
+              </a:spcAft>
+            </a:pPr>
+            <a:r>
+              <a:rPr sz="1250" b="0">
+                <a:solidFill>
+                  <a:srgbClr val="DDE1E6"/>
+                </a:solidFill>
+                <a:latin typeface="Arial"/>
+              </a:rPr>
+              <a:t>Costs </a:t>
+            </a:r>
+            <a:r>
+              <a:rPr sz="1250" b="1">
+                <a:solidFill>
+                  <a:srgbClr val="FFFFFF"/>
+                </a:solidFill>
+                <a:latin typeface="Arial"/>
+              </a:rPr>
+              <a:t>13% fee $91.05, 2% returns $14.01, postage $15.00</a:t>
+            </a:r>
+          </a:p>
+          <a:p>
+            <a:pPr algn="l">
+              <a:spcAft>
+                <a:spcPts val="700"/>
+              </a:spcAft>
+            </a:pPr>
+            <a:r>
+              <a:rPr sz="1250" b="0">
+                <a:solidFill>
+                  <a:srgbClr val="DDE1E6"/>
+                </a:solidFill>
+                <a:latin typeface="Arial"/>
+              </a:rPr>
+              <a:t>Net </a:t>
+            </a:r>
+            <a:r>
+              <a:rPr sz="1250" b="1">
+                <a:solidFill>
+                  <a:srgbClr val="CCFF00"/>
+                </a:solidFill>
+                <a:latin typeface="Arial"/>
+              </a:rPr>
+              <a:t>+$55.36 (10.5%)</a:t>
+            </a:r>
+            <a:r>
+              <a:rPr sz="1250" b="0">
+                <a:solidFill>
+                  <a:srgbClr val="9AA3B2"/>
+                </a:solidFill>
+                <a:latin typeface="Arial"/>
+              </a:rPr>
+              <a:t>, above the 10% margin floor</a:t>
+            </a:r>
+          </a:p>
+          <a:p>
+            <a:pPr algn="l">
+              <a:spcAft>
+                <a:spcPts val="700"/>
+              </a:spcAft>
+            </a:pPr>
+            <a:r>
+              <a:rPr sz="1250" b="1">
+                <a:solidFill>
+                  <a:srgbClr val="FFFFFF"/>
+                </a:solidFill>
+                <a:latin typeface="Arial"/>
+              </a:rPr>
+              <a:t>A proposal now waits for a person. The agent does not buy.</a:t>
+            </a:r>
+          </a:p>
+          <a:p>
+            <a:pPr algn="l">
+              <a:spcAft>
+                <a:spcPts val="700"/>
+              </a:spcAft>
+            </a:pPr>
+            <a:r>
+              <a:rPr sz="1050" b="0">
+                <a:solidFill>
+                  <a:srgbClr val="9AA3B2"/>
+                </a:solidFill>
+                <a:latin typeface="Arial"/>
+              </a:rPr>
+              <a:t>Asking prices, not sold prices. Checked 16 Oct 2026.</a:t>
+            </a:r>
+          </a:p>
+        </p:txBody>
+      </p:sp>
+    </p:spTree>
+  </p:cSld>
+  <p:clrMapOvr>
+    <a:masterClrMapping/>
+  </p:clrMapOvr>
+</p:sld>
+</file>
+
 <file path=ppt/slides/slide2.xml><?xml version="1.0" encoding="utf-8"?>
 <p:sld xmlns:a="http://schemas.openxmlformats.org/drawingml/2006/main" xmlns:p="http://schemas.openxmlformats.org/presentationml/2006/main" xmlns:r="http://schemas.openxmlformats.org/officeDocument/2006/relationships">
   <p:cSld>
@@ -4285,81 +5598,126 @@
           <a:p>
             <a:pPr algn="l">
               <a:spcAft>
-                <a:spcPts val="1400"/>
+                <a:spcPts val="1300"/>
               </a:spcAft>
             </a:pPr>
             <a:r>
-              <a:rPr sz="2100" b="0">
+              <a:rPr sz="1800" b="1">
                 <a:solidFill>
                   <a:srgbClr val="000000"/>
                 </a:solidFill>
                 <a:latin typeface="Arial"/>
               </a:rPr>
-              <a:t>•  SKUdesk is one agent for three jobs: find the cheapest landed cost, price a resale, and check arbitrage.</a:t>
+              <a:t>•  One agent, three jobs. </a:t>
+            </a:r>
+            <a:r>
+              <a:rPr sz="1800" b="0">
+                <a:solidFill>
+                  <a:srgbClr val="555B66"/>
+                </a:solidFill>
+                <a:latin typeface="Arial"/>
+              </a:rPr>
+              <a:t>It finds the cheapest landed cost, prices a resale and checks arbitrage, but only when two listings are the identical product.</a:t>
             </a:r>
           </a:p>
           <a:p>
             <a:pPr algn="l">
               <a:spcAft>
-                <a:spcPts val="1400"/>
+                <a:spcPts val="1300"/>
               </a:spcAft>
             </a:pPr>
             <a:r>
-              <a:rPr sz="2100" b="0">
+              <a:rPr sz="1800" b="1">
                 <a:solidFill>
                   <a:srgbClr val="000000"/>
                 </a:solidFill>
                 <a:latin typeface="Arial"/>
               </a:rPr>
-              <a:t>•  It works only when two listings are the identical product. Gemini decides identity: it must quote the brand and model it relied on, and code checks those quotes are in the listing. A second Gemini step looks at the photo.</a:t>
+              <a:t>•  Gemini is the identity gate. </a:t>
+            </a:r>
+            <a:r>
+              <a:rPr sz="1800" b="0">
+                <a:solidFill>
+                  <a:srgbClr val="555B66"/>
+                </a:solidFill>
+                <a:latin typeface="Arial"/>
+              </a:rPr>
+              <a:t>It must quote the brand and model it relied on, and our code checks that the quotes really appear in the listing. A second Gemini step looks at the photo and can only take a match away.</a:t>
             </a:r>
           </a:p>
           <a:p>
             <a:pPr algn="l">
               <a:spcAft>
-                <a:spcPts val="1400"/>
+                <a:spcPts val="1300"/>
               </a:spcAft>
             </a:pPr>
             <a:r>
-              <a:rPr sz="2100" b="0">
+              <a:rPr sz="1800" b="1">
                 <a:solidFill>
                   <a:srgbClr val="000000"/>
                 </a:solidFill>
                 <a:latin typeface="Arial"/>
               </a:rPr>
-              <a:t>•  The answer is often “no”: no identical product, or no gap left after fees, returns and postage. That is the point. A wrong “yes” loses money.</a:t>
+              <a:t>•  The honest “no” is the product. </a:t>
+            </a:r>
+            <a:r>
+              <a:rPr sz="1800" b="0">
+                <a:solidFill>
+                  <a:srgbClr val="555B66"/>
+                </a:solidFill>
+                <a:latin typeface="Arial"/>
+              </a:rPr>
+              <a:t>No identical product, or no gap left after fees, returns and postage: the agent says so and shows every listing it turned down. A wrong “yes” loses money.</a:t>
             </a:r>
           </a:p>
           <a:p>
             <a:pPr algn="l">
               <a:spcAft>
-                <a:spcPts val="1400"/>
+                <a:spcPts val="1300"/>
               </a:spcAft>
             </a:pPr>
             <a:r>
-              <a:rPr sz="2100" b="0">
+              <a:rPr sz="1800" b="1">
                 <a:solidFill>
                   <a:srgbClr val="000000"/>
                 </a:solidFill>
                 <a:latin typeface="Arial"/>
               </a:rPr>
-              <a:t>•  The agent never spends money. Every buy is a proposal that a person approves. An approved resale can then be listed in Google Merchant Center by the owner.</a:t>
+              <a:t>•  A person approves every spend. </a:t>
+            </a:r>
+            <a:r>
+              <a:rPr sz="1800" b="0">
+                <a:solidFill>
+                  <a:srgbClr val="555B66"/>
+                </a:solidFill>
+                <a:latin typeface="Arial"/>
+              </a:rPr>
+              <a:t>The agent never buys anything itself. Each buy is a proposal; an approved resale can then be listed in Google Merchant Center by the owner.</a:t>
             </a:r>
           </a:p>
           <a:p>
             <a:pPr algn="l">
               <a:spcAft>
-                <a:spcPts val="1400"/>
+                <a:spcPts val="1300"/>
               </a:spcAft>
             </a:pPr>
             <a:r>
-              <a:rPr sz="2100" b="0">
+              <a:rPr sz="1800" b="1">
                 <a:solidFill>
                   <a:srgbClr val="000000"/>
                 </a:solidFill>
                 <a:latin typeface="Arial"/>
               </a:rPr>
-              <a:t>•  Real services end to end: Google Shopping results, Gemini, Cloud Run, Firestore, Cloud Scheduler, Secret Manager and the Merchant API, live at skudesk.lol.</a:t>
+              <a:t>•  Real services, live now. </a:t>
+            </a:r>
+            <a:r>
+              <a:rPr sz="1800" b="0">
+                <a:solidFill>
+                  <a:srgbClr val="555B66"/>
+                </a:solidFill>
+                <a:latin typeface="Arial"/>
+              </a:rPr>
+              <a:t>Google Shopping results, Gemini, Cloud Run, Firestore, Cloud Scheduler, Secret Manager and the Merchant API, at skudesk.lol.</a:t>
             </a:r>
           </a:p>
         </p:txBody>
@@ -4454,7 +5812,7 @@
         <p:spPr>
           <a:xfrm>
             <a:off x="457200" y="1645920"/>
-            <a:ext cx="11247120" cy="4572000"/>
+            <a:ext cx="11247120" cy="3000000"/>
           </a:xfrm>
           <a:prstGeom prst="rect">
             <a:avLst/>
@@ -4469,11 +5827,11 @@
           <a:p>
             <a:pPr algn="l">
               <a:spcAft>
-                <a:spcPts val="1800"/>
+                <a:spcPts val="1000"/>
               </a:spcAft>
             </a:pPr>
             <a:r>
-              <a:rPr b="1" sz="2100">
+              <a:rPr b="1" sz="1700">
                 <a:solidFill>
                   <a:srgbClr val="000000"/>
                 </a:solidFill>
@@ -4482,7 +5840,7 @@
               <a:t>•  How different is it? </a:t>
             </a:r>
             <a:r>
-              <a:rPr sz="2100" b="0">
+              <a:rPr sz="1700" b="0">
                 <a:solidFill>
                   <a:srgbClr val="555B66"/>
                 </a:solidFill>
@@ -4494,11 +5852,11 @@
           <a:p>
             <a:pPr algn="l">
               <a:spcAft>
-                <a:spcPts val="1800"/>
+                <a:spcPts val="1000"/>
               </a:spcAft>
             </a:pPr>
             <a:r>
-              <a:rPr b="1" sz="2100">
+              <a:rPr b="1" sz="1700">
                 <a:solidFill>
                   <a:srgbClr val="000000"/>
                 </a:solidFill>
@@ -4507,7 +5865,7 @@
               <a:t>•  How does it solve the problem? </a:t>
             </a:r>
             <a:r>
-              <a:rPr sz="2100" b="0">
+              <a:rPr sz="1700" b="0">
                 <a:solidFill>
                   <a:srgbClr val="555B66"/>
                 </a:solidFill>
@@ -4519,11 +5877,11 @@
           <a:p>
             <a:pPr algn="l">
               <a:spcAft>
-                <a:spcPts val="1800"/>
+                <a:spcPts val="1000"/>
               </a:spcAft>
             </a:pPr>
             <a:r>
-              <a:rPr b="1" sz="2100">
+              <a:rPr b="1" sz="1700">
                 <a:solidFill>
                   <a:srgbClr val="000000"/>
                 </a:solidFill>
@@ -4532,13 +5890,359 @@
               <a:t>•  USP </a:t>
             </a:r>
             <a:r>
-              <a:rPr sz="2100" b="0">
+              <a:rPr sz="1700" b="0">
                 <a:solidFill>
                   <a:srgbClr val="555B66"/>
                 </a:solidFill>
                 <a:latin typeface="Arial"/>
               </a:rPr>
               <a:t>The honest “no”. 67 labelled product pairs ran against the real model with zero wrong matches, and a person approves every spend. A market view shows asks, four buyer policies’ bids and the spread, so the reason for a “no” is visible.</a:t>
+            </a:r>
+          </a:p>
+        </p:txBody>
+      </p:sp>
+      <p:sp>
+        <p:nvSpPr>
+          <p:cNvPr id="5" name="TextBox 4"/>
+          <p:cNvSpPr txBox="1"/>
+          <p:nvPr/>
+        </p:nvSpPr>
+        <p:spPr>
+          <a:xfrm>
+            <a:off x="457200" y="4325112"/>
+            <a:ext cx="11155680" cy="365760"/>
+          </a:xfrm>
+          <a:prstGeom prst="rect">
+            <a:avLst/>
+          </a:prstGeom>
+          <a:noFill/>
+        </p:spPr>
+        <p:txBody>
+          <a:bodyPr wrap="square" anchor="t" lIns="45720" rIns="45720">
+            <a:spAutoFit/>
+          </a:bodyPr>
+          <a:lstStyle/>
+          <a:p>
+            <a:pPr algn="l">
+              <a:spcAft>
+                <a:spcPts val="0"/>
+              </a:spcAft>
+            </a:pPr>
+            <a:r>
+              <a:rPr sz="1400" b="1">
+                <a:solidFill>
+                  <a:srgbClr val="000000"/>
+                </a:solidFill>
+                <a:latin typeface="Arial"/>
+              </a:rPr>
+              <a:t>Measured on the live service (18 Oct 2026, 12 products watched)</a:t>
+            </a:r>
+          </a:p>
+        </p:txBody>
+      </p:sp>
+      <p:sp>
+        <p:nvSpPr>
+          <p:cNvPr id="6" name="Rounded Rectangle 5"/>
+          <p:cNvSpPr/>
+          <p:nvPr/>
+        </p:nvSpPr>
+        <p:spPr>
+          <a:xfrm>
+            <a:off x="457200" y="4709160"/>
+            <a:ext cx="2651760" cy="1051560"/>
+          </a:xfrm>
+          <a:prstGeom prst="roundRect">
+            <a:avLst>
+              <a:gd name="adj" fmla="val 10000"/>
+            </a:avLst>
+          </a:prstGeom>
+          <a:solidFill>
+            <a:srgbClr val="0B0B0F"/>
+          </a:solidFill>
+          <a:ln>
+            <a:noFill/>
+          </a:ln>
+          <a:effectLst/>
+        </p:spPr>
+        <p:style>
+          <a:lnRef idx="1">
+            <a:schemeClr val="accent1"/>
+          </a:lnRef>
+          <a:fillRef idx="3">
+            <a:schemeClr val="accent1"/>
+          </a:fillRef>
+          <a:effectRef idx="2">
+            <a:schemeClr val="accent1"/>
+          </a:effectRef>
+          <a:fontRef idx="minor">
+            <a:schemeClr val="lt1"/>
+          </a:fontRef>
+        </p:style>
+        <p:txBody>
+          <a:bodyPr rtlCol="0" anchor="ctr" wrap="square" lIns="70000" rIns="70000"/>
+          <a:lstStyle/>
+          <a:p>
+            <a:pPr algn="ctr"/>
+            <a:r>
+              <a:rPr sz="2600" b="1">
+                <a:solidFill>
+                  <a:srgbClr val="CCFF00"/>
+                </a:solidFill>
+                <a:latin typeface="Arial"/>
+              </a:rPr>
+              <a:t>249</a:t>
+            </a:r>
+          </a:p>
+          <a:p>
+            <a:pPr algn="ctr"/>
+            <a:r>
+              <a:rPr sz="1100" b="0">
+                <a:solidFill>
+                  <a:srgbClr val="DDE1E6"/>
+                </a:solidFill>
+                <a:latin typeface="Arial"/>
+              </a:rPr>
+              <a:t>listings screened by the identity gate</a:t>
+            </a:r>
+          </a:p>
+        </p:txBody>
+      </p:sp>
+      <p:sp>
+        <p:nvSpPr>
+          <p:cNvPr id="7" name="Rounded Rectangle 6"/>
+          <p:cNvSpPr/>
+          <p:nvPr/>
+        </p:nvSpPr>
+        <p:spPr>
+          <a:xfrm>
+            <a:off x="3291840" y="4709160"/>
+            <a:ext cx="2651760" cy="1051560"/>
+          </a:xfrm>
+          <a:prstGeom prst="roundRect">
+            <a:avLst>
+              <a:gd name="adj" fmla="val 10000"/>
+            </a:avLst>
+          </a:prstGeom>
+          <a:solidFill>
+            <a:srgbClr val="0B0B0F"/>
+          </a:solidFill>
+          <a:ln>
+            <a:noFill/>
+          </a:ln>
+          <a:effectLst/>
+        </p:spPr>
+        <p:style>
+          <a:lnRef idx="1">
+            <a:schemeClr val="accent1"/>
+          </a:lnRef>
+          <a:fillRef idx="3">
+            <a:schemeClr val="accent1"/>
+          </a:fillRef>
+          <a:effectRef idx="2">
+            <a:schemeClr val="accent1"/>
+          </a:effectRef>
+          <a:fontRef idx="minor">
+            <a:schemeClr val="lt1"/>
+          </a:fontRef>
+        </p:style>
+        <p:txBody>
+          <a:bodyPr rtlCol="0" anchor="ctr" wrap="square" lIns="70000" rIns="70000"/>
+          <a:lstStyle/>
+          <a:p>
+            <a:pPr algn="ctr"/>
+            <a:r>
+              <a:rPr sz="2600" b="1">
+                <a:solidFill>
+                  <a:srgbClr val="CCFF00"/>
+                </a:solidFill>
+                <a:latin typeface="Arial"/>
+              </a:rPr>
+              <a:t>201</a:t>
+            </a:r>
+          </a:p>
+          <a:p>
+            <a:pPr algn="ctr"/>
+            <a:r>
+              <a:rPr sz="1100" b="0">
+                <a:solidFill>
+                  <a:srgbClr val="DDE1E6"/>
+                </a:solidFill>
+                <a:latin typeface="Arial"/>
+              </a:rPr>
+              <a:t>turned down: not the same product (81%)</a:t>
+            </a:r>
+          </a:p>
+        </p:txBody>
+      </p:sp>
+      <p:sp>
+        <p:nvSpPr>
+          <p:cNvPr id="8" name="Rounded Rectangle 7"/>
+          <p:cNvSpPr/>
+          <p:nvPr/>
+        </p:nvSpPr>
+        <p:spPr>
+          <a:xfrm>
+            <a:off x="6126480" y="4709160"/>
+            <a:ext cx="2651760" cy="1051560"/>
+          </a:xfrm>
+          <a:prstGeom prst="roundRect">
+            <a:avLst>
+              <a:gd name="adj" fmla="val 10000"/>
+            </a:avLst>
+          </a:prstGeom>
+          <a:solidFill>
+            <a:srgbClr val="0B0B0F"/>
+          </a:solidFill>
+          <a:ln>
+            <a:noFill/>
+          </a:ln>
+          <a:effectLst/>
+        </p:spPr>
+        <p:style>
+          <a:lnRef idx="1">
+            <a:schemeClr val="accent1"/>
+          </a:lnRef>
+          <a:fillRef idx="3">
+            <a:schemeClr val="accent1"/>
+          </a:fillRef>
+          <a:effectRef idx="2">
+            <a:schemeClr val="accent1"/>
+          </a:effectRef>
+          <a:fontRef idx="minor">
+            <a:schemeClr val="lt1"/>
+          </a:fontRef>
+        </p:style>
+        <p:txBody>
+          <a:bodyPr rtlCol="0" anchor="ctr" wrap="square" lIns="70000" rIns="70000"/>
+          <a:lstStyle/>
+          <a:p>
+            <a:pPr algn="ctr"/>
+            <a:r>
+              <a:rPr sz="2600" b="1">
+                <a:solidFill>
+                  <a:srgbClr val="CCFF00"/>
+                </a:solidFill>
+                <a:latin typeface="Arial"/>
+              </a:rPr>
+              <a:t>14</a:t>
+            </a:r>
+          </a:p>
+          <a:p>
+            <a:pPr algn="ctr"/>
+            <a:r>
+              <a:rPr sz="1100" b="0">
+                <a:solidFill>
+                  <a:srgbClr val="DDE1E6"/>
+                </a:solidFill>
+                <a:latin typeface="Arial"/>
+              </a:rPr>
+              <a:t>impossible prices set aside as bad data</a:t>
+            </a:r>
+          </a:p>
+        </p:txBody>
+      </p:sp>
+      <p:sp>
+        <p:nvSpPr>
+          <p:cNvPr id="9" name="Rounded Rectangle 8"/>
+          <p:cNvSpPr/>
+          <p:nvPr/>
+        </p:nvSpPr>
+        <p:spPr>
+          <a:xfrm>
+            <a:off x="8961120" y="4709160"/>
+            <a:ext cx="2651760" cy="1051560"/>
+          </a:xfrm>
+          <a:prstGeom prst="roundRect">
+            <a:avLst>
+              <a:gd name="adj" fmla="val 10000"/>
+            </a:avLst>
+          </a:prstGeom>
+          <a:solidFill>
+            <a:srgbClr val="0B0B0F"/>
+          </a:solidFill>
+          <a:ln>
+            <a:noFill/>
+          </a:ln>
+          <a:effectLst/>
+        </p:spPr>
+        <p:style>
+          <a:lnRef idx="1">
+            <a:schemeClr val="accent1"/>
+          </a:lnRef>
+          <a:fillRef idx="3">
+            <a:schemeClr val="accent1"/>
+          </a:fillRef>
+          <a:effectRef idx="2">
+            <a:schemeClr val="accent1"/>
+          </a:effectRef>
+          <a:fontRef idx="minor">
+            <a:schemeClr val="lt1"/>
+          </a:fontRef>
+        </p:style>
+        <p:txBody>
+          <a:bodyPr rtlCol="0" anchor="ctr" wrap="square" lIns="70000" rIns="70000"/>
+          <a:lstStyle/>
+          <a:p>
+            <a:pPr algn="ctr"/>
+            <a:r>
+              <a:rPr sz="2600" b="1">
+                <a:solidFill>
+                  <a:srgbClr val="CCFF00"/>
+                </a:solidFill>
+                <a:latin typeface="Arial"/>
+              </a:rPr>
+              <a:t>$6,995</a:t>
+            </a:r>
+          </a:p>
+          <a:p>
+            <a:pPr algn="ctr"/>
+            <a:r>
+              <a:rPr sz="1100" b="0">
+                <a:solidFill>
+                  <a:srgbClr val="DDE1E6"/>
+                </a:solidFill>
+                <a:latin typeface="Arial"/>
+              </a:rPr>
+              <a:t>of fake discounts the agent refused to trade on</a:t>
+            </a:r>
+          </a:p>
+        </p:txBody>
+      </p:sp>
+      <p:sp>
+        <p:nvSpPr>
+          <p:cNvPr id="10" name="TextBox 9"/>
+          <p:cNvSpPr txBox="1"/>
+          <p:nvPr/>
+        </p:nvSpPr>
+        <p:spPr>
+          <a:xfrm>
+            <a:off x="457200" y="5833872"/>
+            <a:ext cx="11155680" cy="365760"/>
+          </a:xfrm>
+          <a:prstGeom prst="rect">
+            <a:avLst/>
+          </a:prstGeom>
+          <a:noFill/>
+        </p:spPr>
+        <p:txBody>
+          <a:bodyPr wrap="square" anchor="t" lIns="45720" rIns="45720">
+            <a:spAutoFit/>
+          </a:bodyPr>
+          <a:lstStyle/>
+          <a:p>
+            <a:pPr algn="l">
+              <a:spcAft>
+                <a:spcPts val="0"/>
+              </a:spcAft>
+            </a:pPr>
+            <a:r>
+              <a:rPr sz="1100" b="0">
+                <a:solidFill>
+                  <a:srgbClr val="555B66"/>
+                </a:solidFill>
+                <a:latin typeface="Arial"/>
+              </a:rPr>
+              <a:t>Figures come from the run-metrics page at skudesk.lol and keep growing as the scheduler checks the watchlist.</a:t>
             </a:r>
           </a:p>
         </p:txBody>

</xml_diff>